<commit_message>
docs: align reviewer deck and grant narrative with the Sept 17 letter
- grant-narrative.md rewritten around MortgageOS 3.1 (MPT note asset + TokenEscrow),
  Fannie Mae/CFPB servicing standard, three operating models, letter milestones
- build-grant-deck.py: Sept 17 date and offices; no clawback/Hook/Xahau/v2/porting;
  Uniform Instruments + Servicing Guide on the compliance slide; Model C (Philippine
  bank shareholding) on the operate slide; M6 = XLS-65/66 readiness; proofs target
  100%; Form 1098 only; partner ask on the closing slide
- letter + deck: transaction count per loan-year aligned to about 60
- checklist: pitch paragraph now points at the narrative; deck/narrative marked aligned

Co-Authored-By: Claude Fable 5.1 <noreply@anthropic.com>
</commit_message>
<xml_diff>
--- a/docs/grant-deck-2026-09-11.pptx
+++ b/docs/grant-deck-2026-09-11.pptx
@@ -3260,7 +3260,7 @@
                 </a:solidFill>
                 <a:latin typeface="Calibri"/>
               </a:rPr>
-              <a:t>XRPL Grants proposal · $200,000 over 12 months · September 11, 2026</a:t>
+              <a:t>XRPL Grants proposal · $200,000 over 12 months · September 17, 2026</a:t>
             </a:r>
           </a:p>
           <a:p>
@@ -3272,7 +3272,7 @@
                 </a:solidFill>
                 <a:latin typeface="Calibri"/>
               </a:rPr>
-              <a:t>High Tech Mortgage, Inc. · Sacramento, California · Metro Manila, Philippines · v3.1 live on Testnet</a:t>
+              <a:t>High Tech Mortgage, Inc. · California · Idaho · Metro Manila · Switzerland opening soon · v3.1 live on Testnet</a:t>
             </a:r>
           </a:p>
         </p:txBody>
@@ -3369,7 +3369,7 @@
                 </a:solidFill>
                 <a:latin typeface="Calibri"/>
               </a:rPr>
-              <a:t>Who we are and how we operate</a:t>
+              <a:t>How we operate</a:t>
             </a:r>
           </a:p>
         </p:txBody>
@@ -3522,7 +3522,7 @@
                 </a:solidFill>
                 <a:latin typeface="Calibri"/>
               </a:rPr>
-              <a:t>•  High Tech Mortgage, Inc.: licensed California mortgage broker (DFPI and DRE), Sacramento, with an operations centre in Manila.</a:t>
+              <a:t>•  High Tech Mortgage, Inc.: licensed California mortgage broker (DFPI and DRE) with offices in California, Idaho and Metro Manila, a Swiss office opening soon, and Manila as the operations centre.</a:t>
             </a:r>
           </a:p>
           <a:p>
@@ -3538,7 +3538,7 @@
                 </a:solidFill>
                 <a:latin typeface="Calibri"/>
               </a:rPr>
-              <a:t>•  Loans: standard Fannie Mae uniform-instrument, fixed-rate, 30-year residential, funded and owned by banks under contract.</a:t>
+              <a:t>•  Loans: standard conventional 30-year fixed-rate residential loans on the Fannie Mae/Freddie Mac Uniform Instruments (Form 3200, Form 3005), serviced to the Fannie Mae Servicing Guide and the CFPB rules under Regulation X and Regulation Z.</a:t>
             </a:r>
           </a:p>
           <a:p>
@@ -3570,7 +3570,7 @@
                 </a:solidFill>
                 <a:latin typeface="Calibri"/>
               </a:rPr>
-              <a:t>•  The Manila team executes servicing tasks under dual control and never holds signing keys.</a:t>
+              <a:t>•  The Manila team executes servicing tasks under dual control in all three models and never holds signing keys.</a:t>
             </a:r>
           </a:p>
         </p:txBody>
@@ -3584,7 +3584,7 @@
         <p:spPr>
           <a:xfrm>
             <a:off x="6400800" y="1280160"/>
-            <a:ext cx="5303520" cy="2194560"/>
+            <a:ext cx="5303520" cy="1508760"/>
           </a:xfrm>
           <a:prstGeom prst="rect">
             <a:avLst/>
@@ -3627,8 +3627,8 @@
         </p:nvSpPr>
         <p:spPr>
           <a:xfrm>
-            <a:off x="6583680" y="1371600"/>
-            <a:ext cx="4937760" cy="457200"/>
+            <a:off x="6583680" y="1325880"/>
+            <a:ext cx="4937760" cy="411480"/>
           </a:xfrm>
           <a:prstGeom prst="rect">
             <a:avLst/>
@@ -3643,7 +3643,7 @@
           <a:p>
             <a:pPr algn="l"/>
             <a:r>
-              <a:rPr sz="1600" b="1">
+              <a:rPr sz="1500" b="1">
                 <a:solidFill>
                   <a:srgbClr val="135BA6"/>
                 </a:solidFill>
@@ -3662,8 +3662,8 @@
         </p:nvSpPr>
         <p:spPr>
           <a:xfrm>
-            <a:off x="6583680" y="1828800"/>
-            <a:ext cx="4937760" cy="1554480"/>
+            <a:off x="6583680" y="1737360"/>
+            <a:ext cx="4937760" cy="1005840"/>
           </a:xfrm>
           <a:prstGeom prst="rect">
             <a:avLst/>
@@ -3678,7 +3678,7 @@
           <a:p>
             <a:pPr algn="l"/>
             <a:r>
-              <a:rPr sz="1400" b="0">
+              <a:rPr sz="1200" b="0">
                 <a:solidFill>
                   <a:srgbClr val="0B2545"/>
                 </a:solidFill>
@@ -3697,8 +3697,8 @@
         </p:nvSpPr>
         <p:spPr>
           <a:xfrm>
-            <a:off x="6400800" y="3749039"/>
-            <a:ext cx="5303520" cy="2286000"/>
+            <a:off x="6400800" y="2880360"/>
+            <a:ext cx="5303520" cy="1508760"/>
           </a:xfrm>
           <a:prstGeom prst="rect">
             <a:avLst/>
@@ -3741,8 +3741,8 @@
         </p:nvSpPr>
         <p:spPr>
           <a:xfrm>
-            <a:off x="6583680" y="3840480"/>
-            <a:ext cx="4937760" cy="457200"/>
+            <a:off x="6583680" y="2926080"/>
+            <a:ext cx="4937760" cy="411480"/>
           </a:xfrm>
           <a:prstGeom prst="rect">
             <a:avLst/>
@@ -3757,7 +3757,7 @@
           <a:p>
             <a:pPr algn="l"/>
             <a:r>
-              <a:rPr sz="1600" b="1">
+              <a:rPr sz="1500" b="1">
                 <a:solidFill>
                   <a:srgbClr val="135BA6"/>
                 </a:solidFill>
@@ -3776,8 +3776,8 @@
         </p:nvSpPr>
         <p:spPr>
           <a:xfrm>
-            <a:off x="6583680" y="4297680"/>
-            <a:ext cx="4937760" cy="1645920"/>
+            <a:off x="6583680" y="3337560"/>
+            <a:ext cx="4937760" cy="1005840"/>
           </a:xfrm>
           <a:prstGeom prst="rect">
             <a:avLst/>
@@ -3792,13 +3792,127 @@
           <a:p>
             <a:pPr algn="l"/>
             <a:r>
-              <a:rPr sz="1400" b="0">
+              <a:rPr sz="1200" b="0">
                 <a:solidFill>
                   <a:srgbClr val="0B2545"/>
                 </a:solidFill>
                 <a:latin typeface="Calibri"/>
               </a:rPr>
               <a:t>A lending bank is the official servicer and keeps banking compliance and liability; HTM runs servicing operations and the technology. Several banks have asked for exactly this.</a:t>
+            </a:r>
+          </a:p>
+        </p:txBody>
+      </p:sp>
+      <p:sp>
+        <p:nvSpPr>
+          <p:cNvPr id="14" name="Rectangle 13"/>
+          <p:cNvSpPr/>
+          <p:nvPr/>
+        </p:nvSpPr>
+        <p:spPr>
+          <a:xfrm>
+            <a:off x="6400800" y="4480560"/>
+            <a:ext cx="5303520" cy="1600200"/>
+          </a:xfrm>
+          <a:prstGeom prst="rect">
+            <a:avLst/>
+          </a:prstGeom>
+          <a:solidFill>
+            <a:srgbClr val="F3F5F8"/>
+          </a:solidFill>
+          <a:ln>
+            <a:noFill/>
+          </a:ln>
+          <a:effectLst/>
+        </p:spPr>
+        <p:style>
+          <a:lnRef idx="1">
+            <a:schemeClr val="accent1"/>
+          </a:lnRef>
+          <a:fillRef idx="3">
+            <a:schemeClr val="accent1"/>
+          </a:fillRef>
+          <a:effectRef idx="2">
+            <a:schemeClr val="accent1"/>
+          </a:effectRef>
+          <a:fontRef idx="minor">
+            <a:schemeClr val="lt1"/>
+          </a:fontRef>
+        </p:style>
+        <p:txBody>
+          <a:bodyPr rtlCol="0" anchor="ctr"/>
+          <a:lstStyle/>
+          <a:p>
+            <a:pPr algn="ctr"/>
+          </a:p>
+        </p:txBody>
+      </p:sp>
+      <p:sp>
+        <p:nvSpPr>
+          <p:cNvPr id="15" name="TextBox 14"/>
+          <p:cNvSpPr txBox="1"/>
+          <p:nvPr/>
+        </p:nvSpPr>
+        <p:spPr>
+          <a:xfrm>
+            <a:off x="6583680" y="4526280"/>
+            <a:ext cx="4937760" cy="411480"/>
+          </a:xfrm>
+          <a:prstGeom prst="rect">
+            <a:avLst/>
+          </a:prstGeom>
+          <a:noFill/>
+        </p:spPr>
+        <p:txBody>
+          <a:bodyPr wrap="square" anchor="t">
+            <a:spAutoFit/>
+          </a:bodyPr>
+          <a:lstStyle/>
+          <a:p>
+            <a:pPr algn="l"/>
+            <a:r>
+              <a:rPr sz="1500" b="1">
+                <a:solidFill>
+                  <a:srgbClr val="135BA6"/>
+                </a:solidFill>
+                <a:latin typeface="Calibri"/>
+              </a:rPr>
+              <a:t>Model C: shareholder in a Philippine bank</a:t>
+            </a:r>
+          </a:p>
+        </p:txBody>
+      </p:sp>
+      <p:sp>
+        <p:nvSpPr>
+          <p:cNvPr id="16" name="TextBox 15"/>
+          <p:cNvSpPr txBox="1"/>
+          <p:nvPr/>
+        </p:nvSpPr>
+        <p:spPr>
+          <a:xfrm>
+            <a:off x="6583680" y="4937760"/>
+            <a:ext cx="4937760" cy="1097280"/>
+          </a:xfrm>
+          <a:prstGeom prst="rect">
+            <a:avLst/>
+          </a:prstGeom>
+          <a:noFill/>
+        </p:spPr>
+        <p:txBody>
+          <a:bodyPr wrap="square" anchor="t">
+            <a:spAutoFit/>
+          </a:bodyPr>
+          <a:lstStyle/>
+          <a:p>
+            <a:pPr algn="l"/>
+            <a:r>
+              <a:rPr sz="1200" b="0">
+                <a:solidFill>
+                  <a:srgbClr val="0B2545"/>
+                </a:solidFill>
+                <a:latin typeface="Calibri"/>
+              </a:rPr>
+              <a:t>HTM intends a 40% position in a small provincial bank near Clark International Airport; the bank originates and owns the loans and MortgageOS services them on XRPL. A partner is invited for up to 20%.</a:t>
             </a:r>
           </a:p>
         </p:txBody>
@@ -4185,7 +4299,7 @@
                           </a:solidFill>
                           <a:latin typeface="Calibri"/>
                         </a:rPr>
-                        <a:t>Counsel memos (CA residential carve-outs, Idaho, custodial asset); first bank servicing contract or LOI; key-management runbook</a:t>
+                        <a:t>Counsel memos (note asset under UCC 3/9, ESIGN/UETA, securities; CA residential carve-outs; Idaho; custodial asset); first bank servicing contract or LOI; key-management runbook</a:t>
                       </a:r>
                     </a:p>
                   </a:txBody>
@@ -4275,7 +4389,7 @@
                           </a:solidFill>
                           <a:latin typeface="Calibri"/>
                         </a:rPr>
-                        <a:t>Port the v2 aggregate analysis and statements onto the v3 core; live tax-bill source behind an operator verification gate; IPFS pinning with the CID verified in the record</a:t>
+                        <a:t>Aggregate escrow analysis (12 CFR 1024.17) and periodic statements (12 CFR 1026.41) on the core; live tax-bill source behind an operator verification gate; IPFS pinning with the CID verified in the asset metadata</a:t>
                       </a:r>
                     </a:p>
                   </a:txBody>
@@ -4297,7 +4411,7 @@
                           </a:solidFill>
                           <a:latin typeface="Calibri"/>
                         </a:rPr>
-                        <a:t>ported tests, verified-bill trail, CID checks</a:t>
+                        <a:t>control tests, verified-bill trail, CID checks</a:t>
                       </a:r>
                     </a:p>
                   </a:txBody>
@@ -4635,7 +4749,7 @@
                           </a:solidFill>
                           <a:latin typeface="Calibri"/>
                         </a:rPr>
-                        <a:t>Second-jurisdiction abstraction: legal layer separated from the engine, mapped for the Manila operation</a:t>
+                        <a:t>XLS-65 / XLS-66 readiness study on Devnet (vault deposit and collateral flows with the note asset); asset-liability policy questions written for the bank</a:t>
                       </a:r>
                     </a:p>
                   </a:txBody>
@@ -4657,7 +4771,7 @@
                           </a:solidFill>
                           <a:latin typeface="Calibri"/>
                         </a:rPr>
-                        <a:t>jurisdiction matrix</a:t>
+                        <a:t>Devnet run record, policy memo</a:t>
                       </a:r>
                     </a:p>
                   </a:txBody>
@@ -5100,7 +5214,7 @@
                           </a:solidFill>
                           <a:latin typeface="Calibri"/>
                         </a:rPr>
-                        <a:t>Servicing and data engineering (porting v2 controls, bank receipts, tax-bill source, cases, PDFs, queue)</a:t>
+                        <a:t>Servicing and data engineering (escrow analysis, statements, cases and Form 1098 on the core; bank receipts; tax-bill source; queue)</a:t>
                       </a:r>
                     </a:p>
                   </a:txBody>
@@ -5238,7 +5352,7 @@
                           </a:solidFill>
                           <a:latin typeface="Calibri"/>
                         </a:rPr>
-                        <a:t>Document and AI ingestion (scanner port, IPFS manifest pinning)</a:t>
+                        <a:t>Document and AI ingestion (closing-package scanner, IPFS manifest pinning)</a:t>
                       </a:r>
                     </a:p>
                   </a:txBody>
@@ -5678,7 +5792,7 @@
                           </a:solidFill>
                           <a:latin typeface="Calibri"/>
                         </a:rPr>
-                        <a:t>Reconciliation accuracy vs benchmark</a:t>
+                        <a:t>Payment proofs re-verified on-ledger</a:t>
                       </a:r>
                     </a:p>
                   </a:txBody>
@@ -5700,7 +5814,7 @@
                           </a:solidFill>
                           <a:latin typeface="Calibri"/>
                         </a:rPr>
-                        <a:t>99 %+</a:t>
+                        <a:t>100 %</a:t>
                       </a:r>
                     </a:p>
                   </a:txBody>
@@ -6107,7 +6221,7 @@
                 </a:solidFill>
                 <a:latin typeface="Calibri"/>
               </a:rPr>
-              <a:t>•  v3 does not yet include the v2 statements, aggregate analysis with cushion, case workflows or Form 1098; they are archived on main and ported in M2–M3.</a:t>
+              <a:t>•  The core settles and proves payments today; aggregate escrow analysis, periodic statements, case workflows and Form 1098 are built on it during M2–M3 and M5.</a:t>
             </a:r>
           </a:p>
           <a:p>
@@ -6559,7 +6673,7 @@
                 </a:solidFill>
                 <a:latin typeface="Calibri"/>
               </a:rPr>
-              <a:t>•  Owns origination, servicing and compliance obligations; licensed principal in both operating models</a:t>
+              <a:t>•  Owns origination, servicing and compliance obligations; licensed principal in the two U.S. operating models</a:t>
             </a:r>
           </a:p>
         </p:txBody>
@@ -6784,7 +6898,7 @@
                 </a:solidFill>
                 <a:latin typeface="Calibri"/>
               </a:rPr>
-              <a:t>•  Real-estate investor since 1998, 120+ transactions, $10M+ portfolio; built v2.0 and v3.0 · linkedin.com/in/drvanwilson</a:t>
+              <a:t>•  Real-estate investor since 1998, 120+ transactions, $10M+ portfolio; designed and wrote MortgageOS · linkedin.com/in/drvanwilson</a:t>
             </a:r>
           </a:p>
         </p:txBody>
@@ -6993,7 +7107,7 @@
                 </a:solidFill>
                 <a:latin typeface="Calibri"/>
               </a:rPr>
-              <a:t>•  CPA (St. Paul University, BA Accounting); Int'l Certified Financial Consultant; ex-internal auditor, Philippine Airlines</a:t>
+              <a:t>•  Former CPA and banker (St. Paul University, BA Accounting); Int'l Certified Financial Consultant; recruited by Megaworld as International Marketing Director</a:t>
             </a:r>
           </a:p>
           <a:p>
@@ -7519,7 +7633,7 @@
                 </a:solidFill>
                 <a:latin typeface="Calibri"/>
               </a:rPr>
-              <a:t>•  Introductions to banks that outsource servicing operations, and to the RLUSD / institutional team on the custodial-asset question.</a:t>
+              <a:t>•  A partner for up to a 20% share of the provincial bank acquisition near Clark, so the acquisition and the XRPL rollout move faster.</a:t>
             </a:r>
           </a:p>
           <a:p>
@@ -7535,7 +7649,23 @@
                 </a:solidFill>
                 <a:latin typeface="Calibri"/>
               </a:rPr>
-              <a:t>•  Everything stays open source: the mortgageos schema, the note-asset MPT pattern and metadata, the memo format, the transaction builders, the payment-proof and audit-log contract, the Hook firewall.</a:t>
+              <a:t>•  Introductions to banks that outsource servicing operations, and to the RLUSD / institutional team on the custodial-asset question.</a:t>
+            </a:r>
+          </a:p>
+          <a:p>
+            <a:pPr>
+              <a:spcAft>
+                <a:spcPts val="600"/>
+              </a:spcAft>
+            </a:pPr>
+            <a:r>
+              <a:rPr sz="1600">
+                <a:solidFill>
+                  <a:srgbClr val="0B2545"/>
+                </a:solidFill>
+                <a:latin typeface="Calibri"/>
+              </a:rPr>
+              <a:t>•  Everything stays open source: the mortgageos schema, the note-asset MPT pattern and metadata, the memo format, the transaction builders, the payment-proof and audit-log contract.</a:t>
             </a:r>
           </a:p>
           <a:p>
@@ -8531,7 +8661,7 @@
                 </a:solidFill>
                 <a:latin typeface="Calibri"/>
               </a:rPr>
-              <a:t>•  CanEscrow + CanTransfer + CanLock + RequireAuth; never clawback</a:t>
+              <a:t>•  CanEscrow + CanTransfer + CanLock + RequireAuth; the issuer cannot take units back</a:t>
             </a:r>
           </a:p>
           <a:p>
@@ -9970,7 +10100,7 @@
                 </a:solidFill>
                 <a:latin typeface="Calibri"/>
               </a:rPr>
-              <a:t>•  Phase 1: DepositAuth and Preauth set and read back; the note asset minted with CanEscrow, CanTransfer, CanLock, RequireAuth and no CanClawback, its metadata carrying the fixed terms; the lender authorized and delivered 45,000,000 units (face value); ledger issuance id equals the database row.</a:t>
+              <a:t>•  Phase 1: DepositAuth and Preauth set and read back; the note asset minted with CanEscrow, CanTransfer, CanLock and RequireAuth, its metadata carrying the fixed terms; the lender authorized and delivered 45,000,000 units (face value); ledger issuance id equals the database row.</a:t>
             </a:r>
           </a:p>
           <a:p>
@@ -10493,7 +10623,7 @@
                 </a:solidFill>
                 <a:latin typeface="Calibri"/>
               </a:rPr>
-              <a:t>Only amendments live on Mainnet: MPTokensV1, TokenEscrow, DepositAuth, DepositPreauth. Evidence: docs/evidence/v3/. Hook firewall proven on Xahau: hooks/evidence/.</a:t>
+              <a:t>Only amendments live on Mainnet: MPTokensV1, TokenEscrow, DepositAuth, DepositPreauth. Evidence: docs/evidence/v3/.</a:t>
             </a:r>
           </a:p>
         </p:txBody>
@@ -11282,7 +11412,7 @@
                 </a:solidFill>
                 <a:latin typeface="Calibri"/>
               </a:rPr>
-              <a:t>Regulation as code: what v3 enforces today and what is ported next</a:t>
+              <a:t>Regulation as code: what the core enforces today and what is built next</a:t>
             </a:r>
           </a:p>
         </p:txBody>
@@ -11459,7 +11589,7 @@
                           </a:solidFill>
                           <a:latin typeface="Calibri"/>
                         </a:rPr>
-                        <a:t>v3.0 today</a:t>
+                        <a:t>Core today</a:t>
                       </a:r>
                     </a:p>
                   </a:txBody>
@@ -11481,7 +11611,7 @@
                           </a:solidFill>
                           <a:latin typeface="Calibri"/>
                         </a:rPr>
-                        <a:t>Ported from v2 during M2–M3</a:t>
+                        <a:t>Built on the core during M2–M3</a:t>
                       </a:r>
                     </a:p>
                   </a:txBody>
@@ -11821,7 +11951,7 @@
                           </a:solidFill>
                           <a:latin typeface="Calibri"/>
                         </a:rPr>
-                        <a:t>Form 1098, 1099-INT</a:t>
+                        <a:t>Form 1098 (26 U.S.C. § 6050H)</a:t>
                       </a:r>
                     </a:p>
                   </a:txBody>
@@ -11866,7 +11996,7 @@
                 </a:solidFill>
                 <a:latin typeface="Calibri"/>
               </a:rPr>
-              <a:t>The v2 control map (R01–R31, 127 named tests) is archived on main and is the porting roadmap, not a v3 feature. v3 is graded by a live suite that ends in a reconciliation sweep and prints a single pass string only when every phase passed.</a:t>
+              <a:t>Loans are documented on the Fannie Mae/Freddie Mac Uniform Instruments (Form 3200 note, Form 3005 California deed of trust) and serviced to the Fannie Mae Servicing Guide (B-1-01 escrow administration, C-1.1-01 payment processing). The core is graded by a live suite that ends in an audit sweep and prints a single pass string only when every phase passed.</a:t>
             </a:r>
           </a:p>
         </p:txBody>
@@ -12649,7 +12779,7 @@
                           </a:solidFill>
                           <a:latin typeface="Calibri"/>
                         </a:rPr>
-                        <a:t>about 55</a:t>
+                        <a:t>about 60</a:t>
                       </a:r>
                     </a:p>
                   </a:txBody>
@@ -12673,7 +12803,7 @@
                           </a:solidFill>
                           <a:latin typeface="Calibri"/>
                         </a:rPr>
-                        <a:t>Fees burned (10 drops each)</a:t>
+                        <a:t>Fees (10 drops each)</a:t>
                       </a:r>
                     </a:p>
                   </a:txBody>
@@ -12695,7 +12825,7 @@
                           </a:solidFill>
                           <a:latin typeface="Calibri"/>
                         </a:rPr>
-                        <a:t>about 550 drops</a:t>
+                        <a:t>about 600 drops</a:t>
                       </a:r>
                     </a:p>
                   </a:txBody>

</xml_diff>